<commit_message>
Banner cards: photo above the name band so faces stay clear
</commit_message>
<xml_diff>
--- a/templates/posts/october/2026-10-05-mon-ig-teachers-day-banner-cards-alt.pptx
+++ b/templates/posts/october/2026-10-05-mon-ig-teachers-day-banner-cards-alt.pptx
@@ -3802,7 +3802,7 @@
       <p:grpSpPr/>
       <p:pic>
         <p:nvPicPr>
-          <p:cNvPr id="2" name="Picture 1" descr="7699113808067708069.jpg"/>
+          <p:cNvPr id="2" name="Picture 1" descr="4276041248470525378.jpg"/>
           <p:cNvPicPr>
             <a:picLocks noChangeAspect="1"/>
           </p:cNvPicPr>
@@ -3817,7 +3817,7 @@
         <p:spPr>
           <a:xfrm>
             <a:off x="0" y="0"/>
-            <a:ext cx="10287000" cy="12858750"/>
+            <a:ext cx="10287000" cy="9620250"/>
           </a:xfrm>
           <a:prstGeom prst="rect">
             <a:avLst/>
@@ -4497,11 +4497,11 @@
         <p:spPr>
           <a:xfrm>
             <a:off x="-571500" y="-571500"/>
-            <a:ext cx="5905500" cy="3048000"/>
+            <a:ext cx="4381500" cy="2476500"/>
           </a:xfrm>
           <a:prstGeom prst="roundRect">
             <a:avLst>
-              <a:gd name="adj" fmla="val 12500"/>
+              <a:gd name="adj" fmla="val 15384"/>
             </a:avLst>
           </a:prstGeom>
           <a:solidFill>
@@ -4544,8 +4544,8 @@
         </p:nvSpPr>
         <p:spPr>
           <a:xfrm>
-            <a:off x="666750" y="571500"/>
-            <a:ext cx="1238250" cy="1238250"/>
+            <a:off x="571500" y="476250"/>
+            <a:ext cx="952500" cy="952500"/>
           </a:xfrm>
           <a:prstGeom prst="ellipse">
             <a:avLst/>
@@ -4588,8 +4588,8 @@
         </p:nvSpPr>
         <p:spPr>
           <a:xfrm>
-            <a:off x="666750" y="571500"/>
-            <a:ext cx="1238250" cy="1238250"/>
+            <a:off x="571500" y="476250"/>
+            <a:ext cx="952500" cy="952500"/>
           </a:xfrm>
           <a:prstGeom prst="rect">
             <a:avLst/>
@@ -4627,8 +4627,8 @@
         </p:nvSpPr>
         <p:spPr>
           <a:xfrm>
-            <a:off x="2571750" y="666750"/>
-            <a:ext cx="19050" cy="1143000"/>
+            <a:off x="1809750" y="523875"/>
+            <a:ext cx="19050" cy="857250"/>
           </a:xfrm>
           <a:prstGeom prst="rect">
             <a:avLst/>
@@ -4671,8 +4671,8 @@
         </p:nvSpPr>
         <p:spPr>
           <a:xfrm>
-            <a:off x="3048000" y="571500"/>
-            <a:ext cx="1238250" cy="1238250"/>
+            <a:off x="2190750" y="476250"/>
+            <a:ext cx="952500" cy="952500"/>
           </a:xfrm>
           <a:prstGeom prst="ellipse">
             <a:avLst/>
@@ -4715,8 +4715,8 @@
         </p:nvSpPr>
         <p:spPr>
           <a:xfrm>
-            <a:off x="3048000" y="571500"/>
-            <a:ext cx="1238250" cy="1238250"/>
+            <a:off x="2190750" y="476250"/>
+            <a:ext cx="952500" cy="952500"/>
           </a:xfrm>
           <a:prstGeom prst="rect">
             <a:avLst/>
@@ -4754,7 +4754,51 @@
         </p:nvSpPr>
         <p:spPr>
           <a:xfrm>
-            <a:off x="0" y="7620000"/>
+            <a:off x="0" y="9620250"/>
+            <a:ext cx="10287000" cy="3238500"/>
+          </a:xfrm>
+          <a:prstGeom prst="rect">
+            <a:avLst/>
+          </a:prstGeom>
+          <a:solidFill>
+            <a:srgbClr val="22371F"/>
+          </a:solidFill>
+          <a:ln>
+            <a:noFill/>
+          </a:ln>
+          <a:effectLst/>
+        </p:spPr>
+        <p:style>
+          <a:lnRef idx="1">
+            <a:schemeClr val="accent1"/>
+          </a:lnRef>
+          <a:fillRef idx="3">
+            <a:schemeClr val="accent1"/>
+          </a:fillRef>
+          <a:effectRef idx="2">
+            <a:schemeClr val="accent1"/>
+          </a:effectRef>
+          <a:fontRef idx="minor">
+            <a:schemeClr val="lt1"/>
+          </a:fontRef>
+        </p:style>
+        <p:txBody>
+          <a:bodyPr rtlCol="0" anchor="ctr"/>
+          <a:lstStyle/>
+          <a:p>
+            <a:pPr algn="ctr"/>
+          </a:p>
+        </p:txBody>
+      </p:sp>
+      <p:sp>
+        <p:nvSpPr>
+          <p:cNvPr id="18" name="Rectangle 17"/>
+          <p:cNvSpPr/>
+          <p:nvPr/>
+        </p:nvSpPr>
+        <p:spPr>
+          <a:xfrm>
+            <a:off x="0" y="8953500"/>
             <a:ext cx="10287000" cy="2190750"/>
           </a:xfrm>
           <a:prstGeom prst="rect">
@@ -4762,7 +4806,7 @@
           </a:prstGeom>
           <a:solidFill>
             <a:srgbClr val="22371F">
-              <a:alpha val="72000"/>
+              <a:alpha val="78000"/>
             </a:srgbClr>
           </a:solidFill>
           <a:ln>
@@ -4794,13 +4838,13 @@
       </p:sp>
       <p:sp>
         <p:nvSpPr>
-          <p:cNvPr id="18" name="Rectangle 17"/>
+          <p:cNvPr id="19" name="Rectangle 18"/>
           <p:cNvSpPr/>
           <p:nvPr/>
         </p:nvSpPr>
         <p:spPr>
           <a:xfrm>
-            <a:off x="0" y="7581900"/>
+            <a:off x="0" y="8915400"/>
             <a:ext cx="10287000" cy="38100"/>
           </a:xfrm>
           <a:prstGeom prst="rect">
@@ -4838,13 +4882,13 @@
       </p:sp>
       <p:sp>
         <p:nvSpPr>
-          <p:cNvPr id="19" name="Rectangle 18"/>
+          <p:cNvPr id="20" name="Rectangle 19"/>
           <p:cNvSpPr/>
           <p:nvPr/>
         </p:nvSpPr>
         <p:spPr>
           <a:xfrm>
-            <a:off x="0" y="7734300"/>
+            <a:off x="0" y="9048750"/>
             <a:ext cx="10287000" cy="19050"/>
           </a:xfrm>
           <a:prstGeom prst="rect">
@@ -4882,13 +4926,13 @@
       </p:sp>
       <p:sp>
         <p:nvSpPr>
-          <p:cNvPr id="20" name="Rectangle 19"/>
+          <p:cNvPr id="21" name="Rectangle 20"/>
           <p:cNvSpPr/>
           <p:nvPr/>
         </p:nvSpPr>
         <p:spPr>
           <a:xfrm>
-            <a:off x="0" y="9810750"/>
+            <a:off x="0" y="11144250"/>
             <a:ext cx="10287000" cy="38100"/>
           </a:xfrm>
           <a:prstGeom prst="rect">
@@ -4926,13 +4970,13 @@
       </p:sp>
       <p:sp>
         <p:nvSpPr>
-          <p:cNvPr id="21" name="TextBox 20"/>
+          <p:cNvPr id="22" name="TextBox 21"/>
           <p:cNvSpPr txBox="1"/>
           <p:nvPr/>
         </p:nvSpPr>
         <p:spPr>
           <a:xfrm>
-            <a:off x="762000" y="7905750"/>
+            <a:off x="762000" y="9191625"/>
             <a:ext cx="8572500" cy="1047750"/>
           </a:xfrm>
           <a:prstGeom prst="rect">
@@ -4965,13 +5009,13 @@
       </p:sp>
       <p:sp>
         <p:nvSpPr>
-          <p:cNvPr id="22" name="TextBox 21"/>
+          <p:cNvPr id="23" name="TextBox 22"/>
           <p:cNvSpPr txBox="1"/>
           <p:nvPr/>
         </p:nvSpPr>
         <p:spPr>
           <a:xfrm>
-            <a:off x="762000" y="8905875"/>
+            <a:off x="762000" y="10191750"/>
             <a:ext cx="8572500" cy="666750"/>
           </a:xfrm>
           <a:prstGeom prst="rect">
@@ -4998,6 +5042,45 @@
                 <a:latin typeface="Source Sans 3"/>
               </a:rPr>
               <a:t>SCIENCE LEADER</a:t>
+            </a:r>
+          </a:p>
+        </p:txBody>
+      </p:sp>
+      <p:sp>
+        <p:nvSpPr>
+          <p:cNvPr id="24" name="TextBox 23"/>
+          <p:cNvSpPr txBox="1"/>
+          <p:nvPr/>
+        </p:nvSpPr>
+        <p:spPr>
+          <a:xfrm>
+            <a:off x="762000" y="11763375"/>
+            <a:ext cx="8763000" cy="476250"/>
+          </a:xfrm>
+          <a:prstGeom prst="rect">
+            <a:avLst/>
+          </a:prstGeom>
+          <a:noFill/>
+        </p:spPr>
+        <p:txBody>
+          <a:bodyPr wrap="square" lIns="0" rIns="0" tIns="0" bIns="0" anchor="t">
+            <a:spAutoFit/>
+          </a:bodyPr>
+          <a:lstStyle/>
+          <a:p>
+            <a:pPr algn="l">
+              <a:lnSpc>
+                <a:spcPct val="120000"/>
+              </a:lnSpc>
+            </a:pPr>
+            <a:r>
+              <a:rPr sz="3000" b="0" i="0">
+                <a:solidFill>
+                  <a:srgbClr val="F4F1EA"/>
+                </a:solidFill>
+                <a:latin typeface="Source Sans 3"/>
+              </a:rPr>
+              <a:t>@soilfoodwebschool</a:t>
             </a:r>
           </a:p>
         </p:txBody>
@@ -5030,7 +5113,7 @@
       <p:grpSpPr/>
       <p:pic>
         <p:nvPicPr>
-          <p:cNvPr id="2" name="Picture 1" descr="6892541509162598841.jpg"/>
+          <p:cNvPr id="2" name="Picture 1" descr="5080328754071181355.jpg"/>
           <p:cNvPicPr>
             <a:picLocks noChangeAspect="1"/>
           </p:cNvPicPr>
@@ -5045,7 +5128,7 @@
         <p:spPr>
           <a:xfrm>
             <a:off x="0" y="0"/>
-            <a:ext cx="10287000" cy="12858750"/>
+            <a:ext cx="10287000" cy="9620250"/>
           </a:xfrm>
           <a:prstGeom prst="rect">
             <a:avLst/>
@@ -5725,11 +5808,11 @@
         <p:spPr>
           <a:xfrm>
             <a:off x="-571500" y="-571500"/>
-            <a:ext cx="5905500" cy="3048000"/>
+            <a:ext cx="4381500" cy="2476500"/>
           </a:xfrm>
           <a:prstGeom prst="roundRect">
             <a:avLst>
-              <a:gd name="adj" fmla="val 12500"/>
+              <a:gd name="adj" fmla="val 15384"/>
             </a:avLst>
           </a:prstGeom>
           <a:solidFill>
@@ -5772,8 +5855,8 @@
         </p:nvSpPr>
         <p:spPr>
           <a:xfrm>
-            <a:off x="666750" y="571500"/>
-            <a:ext cx="1238250" cy="1238250"/>
+            <a:off x="571500" y="476250"/>
+            <a:ext cx="952500" cy="952500"/>
           </a:xfrm>
           <a:prstGeom prst="ellipse">
             <a:avLst/>
@@ -5816,8 +5899,8 @@
         </p:nvSpPr>
         <p:spPr>
           <a:xfrm>
-            <a:off x="666750" y="571500"/>
-            <a:ext cx="1238250" cy="1238250"/>
+            <a:off x="571500" y="476250"/>
+            <a:ext cx="952500" cy="952500"/>
           </a:xfrm>
           <a:prstGeom prst="rect">
             <a:avLst/>
@@ -5855,8 +5938,8 @@
         </p:nvSpPr>
         <p:spPr>
           <a:xfrm>
-            <a:off x="2571750" y="666750"/>
-            <a:ext cx="19050" cy="1143000"/>
+            <a:off x="1809750" y="523875"/>
+            <a:ext cx="19050" cy="857250"/>
           </a:xfrm>
           <a:prstGeom prst="rect">
             <a:avLst/>
@@ -5899,8 +5982,8 @@
         </p:nvSpPr>
         <p:spPr>
           <a:xfrm>
-            <a:off x="3048000" y="571500"/>
-            <a:ext cx="1238250" cy="1238250"/>
+            <a:off x="2190750" y="476250"/>
+            <a:ext cx="952500" cy="952500"/>
           </a:xfrm>
           <a:prstGeom prst="ellipse">
             <a:avLst/>
@@ -5943,8 +6026,8 @@
         </p:nvSpPr>
         <p:spPr>
           <a:xfrm>
-            <a:off x="3048000" y="571500"/>
-            <a:ext cx="1238250" cy="1238250"/>
+            <a:off x="2190750" y="476250"/>
+            <a:ext cx="952500" cy="952500"/>
           </a:xfrm>
           <a:prstGeom prst="rect">
             <a:avLst/>
@@ -5982,7 +6065,51 @@
         </p:nvSpPr>
         <p:spPr>
           <a:xfrm>
-            <a:off x="0" y="7620000"/>
+            <a:off x="0" y="9620250"/>
+            <a:ext cx="10287000" cy="3238500"/>
+          </a:xfrm>
+          <a:prstGeom prst="rect">
+            <a:avLst/>
+          </a:prstGeom>
+          <a:solidFill>
+            <a:srgbClr val="22371F"/>
+          </a:solidFill>
+          <a:ln>
+            <a:noFill/>
+          </a:ln>
+          <a:effectLst/>
+        </p:spPr>
+        <p:style>
+          <a:lnRef idx="1">
+            <a:schemeClr val="accent1"/>
+          </a:lnRef>
+          <a:fillRef idx="3">
+            <a:schemeClr val="accent1"/>
+          </a:fillRef>
+          <a:effectRef idx="2">
+            <a:schemeClr val="accent1"/>
+          </a:effectRef>
+          <a:fontRef idx="minor">
+            <a:schemeClr val="lt1"/>
+          </a:fontRef>
+        </p:style>
+        <p:txBody>
+          <a:bodyPr rtlCol="0" anchor="ctr"/>
+          <a:lstStyle/>
+          <a:p>
+            <a:pPr algn="ctr"/>
+          </a:p>
+        </p:txBody>
+      </p:sp>
+      <p:sp>
+        <p:nvSpPr>
+          <p:cNvPr id="18" name="Rectangle 17"/>
+          <p:cNvSpPr/>
+          <p:nvPr/>
+        </p:nvSpPr>
+        <p:spPr>
+          <a:xfrm>
+            <a:off x="0" y="8953500"/>
             <a:ext cx="10287000" cy="2190750"/>
           </a:xfrm>
           <a:prstGeom prst="rect">
@@ -5990,7 +6117,7 @@
           </a:prstGeom>
           <a:solidFill>
             <a:srgbClr val="22371F">
-              <a:alpha val="72000"/>
+              <a:alpha val="78000"/>
             </a:srgbClr>
           </a:solidFill>
           <a:ln>
@@ -6022,13 +6149,13 @@
       </p:sp>
       <p:sp>
         <p:nvSpPr>
-          <p:cNvPr id="18" name="Rectangle 17"/>
+          <p:cNvPr id="19" name="Rectangle 18"/>
           <p:cNvSpPr/>
           <p:nvPr/>
         </p:nvSpPr>
         <p:spPr>
           <a:xfrm>
-            <a:off x="0" y="7581900"/>
+            <a:off x="0" y="8915400"/>
             <a:ext cx="10287000" cy="38100"/>
           </a:xfrm>
           <a:prstGeom prst="rect">
@@ -6066,13 +6193,13 @@
       </p:sp>
       <p:sp>
         <p:nvSpPr>
-          <p:cNvPr id="19" name="Rectangle 18"/>
+          <p:cNvPr id="20" name="Rectangle 19"/>
           <p:cNvSpPr/>
           <p:nvPr/>
         </p:nvSpPr>
         <p:spPr>
           <a:xfrm>
-            <a:off x="0" y="7734300"/>
+            <a:off x="0" y="9048750"/>
             <a:ext cx="10287000" cy="19050"/>
           </a:xfrm>
           <a:prstGeom prst="rect">
@@ -6110,13 +6237,13 @@
       </p:sp>
       <p:sp>
         <p:nvSpPr>
-          <p:cNvPr id="20" name="Rectangle 19"/>
+          <p:cNvPr id="21" name="Rectangle 20"/>
           <p:cNvSpPr/>
           <p:nvPr/>
         </p:nvSpPr>
         <p:spPr>
           <a:xfrm>
-            <a:off x="0" y="9810750"/>
+            <a:off x="0" y="11144250"/>
             <a:ext cx="10287000" cy="38100"/>
           </a:xfrm>
           <a:prstGeom prst="rect">
@@ -6154,13 +6281,13 @@
       </p:sp>
       <p:sp>
         <p:nvSpPr>
-          <p:cNvPr id="21" name="TextBox 20"/>
+          <p:cNvPr id="22" name="TextBox 21"/>
           <p:cNvSpPr txBox="1"/>
           <p:nvPr/>
         </p:nvSpPr>
         <p:spPr>
           <a:xfrm>
-            <a:off x="762000" y="7905750"/>
+            <a:off x="762000" y="9191625"/>
             <a:ext cx="8572500" cy="1047750"/>
           </a:xfrm>
           <a:prstGeom prst="rect">
@@ -6193,13 +6320,13 @@
       </p:sp>
       <p:sp>
         <p:nvSpPr>
-          <p:cNvPr id="22" name="TextBox 21"/>
+          <p:cNvPr id="23" name="TextBox 22"/>
           <p:cNvSpPr txBox="1"/>
           <p:nvPr/>
         </p:nvSpPr>
         <p:spPr>
           <a:xfrm>
-            <a:off x="762000" y="8905875"/>
+            <a:off x="762000" y="10191750"/>
             <a:ext cx="8572500" cy="666750"/>
           </a:xfrm>
           <a:prstGeom prst="rect">
@@ -6226,6 +6353,45 @@
                 <a:latin typeface="Source Sans 3"/>
               </a:rPr>
               <a:t>FARMER, NORFOLK</a:t>
+            </a:r>
+          </a:p>
+        </p:txBody>
+      </p:sp>
+      <p:sp>
+        <p:nvSpPr>
+          <p:cNvPr id="24" name="TextBox 23"/>
+          <p:cNvSpPr txBox="1"/>
+          <p:nvPr/>
+        </p:nvSpPr>
+        <p:spPr>
+          <a:xfrm>
+            <a:off x="762000" y="11763375"/>
+            <a:ext cx="8763000" cy="476250"/>
+          </a:xfrm>
+          <a:prstGeom prst="rect">
+            <a:avLst/>
+          </a:prstGeom>
+          <a:noFill/>
+        </p:spPr>
+        <p:txBody>
+          <a:bodyPr wrap="square" lIns="0" rIns="0" tIns="0" bIns="0" anchor="t">
+            <a:spAutoFit/>
+          </a:bodyPr>
+          <a:lstStyle/>
+          <a:p>
+            <a:pPr algn="l">
+              <a:lnSpc>
+                <a:spcPct val="120000"/>
+              </a:lnSpc>
+            </a:pPr>
+            <a:r>
+              <a:rPr sz="3000" b="0" i="0">
+                <a:solidFill>
+                  <a:srgbClr val="F4F1EA"/>
+                </a:solidFill>
+                <a:latin typeface="Source Sans 3"/>
+              </a:rPr>
+              <a:t>@soilfoodwebschool</a:t>
             </a:r>
           </a:p>
         </p:txBody>
@@ -6258,7 +6424,7 @@
       <p:grpSpPr/>
       <p:pic>
         <p:nvPicPr>
-          <p:cNvPr id="2" name="Picture 1" descr="7500802371811747991.jpg"/>
+          <p:cNvPr id="2" name="Picture 1" descr="1186483563729423873.jpg"/>
           <p:cNvPicPr>
             <a:picLocks noChangeAspect="1"/>
           </p:cNvPicPr>
@@ -6273,7 +6439,7 @@
         <p:spPr>
           <a:xfrm>
             <a:off x="0" y="0"/>
-            <a:ext cx="10287000" cy="12858750"/>
+            <a:ext cx="10287000" cy="9620250"/>
           </a:xfrm>
           <a:prstGeom prst="rect">
             <a:avLst/>
@@ -6953,11 +7119,11 @@
         <p:spPr>
           <a:xfrm>
             <a:off x="-571500" y="-571500"/>
-            <a:ext cx="5905500" cy="3048000"/>
+            <a:ext cx="4381500" cy="2476500"/>
           </a:xfrm>
           <a:prstGeom prst="roundRect">
             <a:avLst>
-              <a:gd name="adj" fmla="val 12500"/>
+              <a:gd name="adj" fmla="val 15384"/>
             </a:avLst>
           </a:prstGeom>
           <a:solidFill>
@@ -7000,8 +7166,8 @@
         </p:nvSpPr>
         <p:spPr>
           <a:xfrm>
-            <a:off x="666750" y="571500"/>
-            <a:ext cx="1238250" cy="1238250"/>
+            <a:off x="571500" y="476250"/>
+            <a:ext cx="952500" cy="952500"/>
           </a:xfrm>
           <a:prstGeom prst="ellipse">
             <a:avLst/>
@@ -7044,8 +7210,8 @@
         </p:nvSpPr>
         <p:spPr>
           <a:xfrm>
-            <a:off x="666750" y="571500"/>
-            <a:ext cx="1238250" cy="1238250"/>
+            <a:off x="571500" y="476250"/>
+            <a:ext cx="952500" cy="952500"/>
           </a:xfrm>
           <a:prstGeom prst="rect">
             <a:avLst/>
@@ -7083,8 +7249,8 @@
         </p:nvSpPr>
         <p:spPr>
           <a:xfrm>
-            <a:off x="2571750" y="666750"/>
-            <a:ext cx="19050" cy="1143000"/>
+            <a:off x="1809750" y="523875"/>
+            <a:ext cx="19050" cy="857250"/>
           </a:xfrm>
           <a:prstGeom prst="rect">
             <a:avLst/>
@@ -7127,8 +7293,8 @@
         </p:nvSpPr>
         <p:spPr>
           <a:xfrm>
-            <a:off x="3048000" y="571500"/>
-            <a:ext cx="1238250" cy="1238250"/>
+            <a:off x="2190750" y="476250"/>
+            <a:ext cx="952500" cy="952500"/>
           </a:xfrm>
           <a:prstGeom prst="ellipse">
             <a:avLst/>
@@ -7171,8 +7337,8 @@
         </p:nvSpPr>
         <p:spPr>
           <a:xfrm>
-            <a:off x="3048000" y="571500"/>
-            <a:ext cx="1238250" cy="1238250"/>
+            <a:off x="2190750" y="476250"/>
+            <a:ext cx="952500" cy="952500"/>
           </a:xfrm>
           <a:prstGeom prst="rect">
             <a:avLst/>
@@ -7210,7 +7376,51 @@
         </p:nvSpPr>
         <p:spPr>
           <a:xfrm>
-            <a:off x="0" y="7620000"/>
+            <a:off x="0" y="9620250"/>
+            <a:ext cx="10287000" cy="3238500"/>
+          </a:xfrm>
+          <a:prstGeom prst="rect">
+            <a:avLst/>
+          </a:prstGeom>
+          <a:solidFill>
+            <a:srgbClr val="22371F"/>
+          </a:solidFill>
+          <a:ln>
+            <a:noFill/>
+          </a:ln>
+          <a:effectLst/>
+        </p:spPr>
+        <p:style>
+          <a:lnRef idx="1">
+            <a:schemeClr val="accent1"/>
+          </a:lnRef>
+          <a:fillRef idx="3">
+            <a:schemeClr val="accent1"/>
+          </a:fillRef>
+          <a:effectRef idx="2">
+            <a:schemeClr val="accent1"/>
+          </a:effectRef>
+          <a:fontRef idx="minor">
+            <a:schemeClr val="lt1"/>
+          </a:fontRef>
+        </p:style>
+        <p:txBody>
+          <a:bodyPr rtlCol="0" anchor="ctr"/>
+          <a:lstStyle/>
+          <a:p>
+            <a:pPr algn="ctr"/>
+          </a:p>
+        </p:txBody>
+      </p:sp>
+      <p:sp>
+        <p:nvSpPr>
+          <p:cNvPr id="18" name="Rectangle 17"/>
+          <p:cNvSpPr/>
+          <p:nvPr/>
+        </p:nvSpPr>
+        <p:spPr>
+          <a:xfrm>
+            <a:off x="0" y="8953500"/>
             <a:ext cx="10287000" cy="2190750"/>
           </a:xfrm>
           <a:prstGeom prst="rect">
@@ -7218,7 +7428,7 @@
           </a:prstGeom>
           <a:solidFill>
             <a:srgbClr val="22371F">
-              <a:alpha val="72000"/>
+              <a:alpha val="78000"/>
             </a:srgbClr>
           </a:solidFill>
           <a:ln>
@@ -7250,13 +7460,13 @@
       </p:sp>
       <p:sp>
         <p:nvSpPr>
-          <p:cNvPr id="18" name="Rectangle 17"/>
+          <p:cNvPr id="19" name="Rectangle 18"/>
           <p:cNvSpPr/>
           <p:nvPr/>
         </p:nvSpPr>
         <p:spPr>
           <a:xfrm>
-            <a:off x="0" y="7581900"/>
+            <a:off x="0" y="8915400"/>
             <a:ext cx="10287000" cy="38100"/>
           </a:xfrm>
           <a:prstGeom prst="rect">
@@ -7294,13 +7504,13 @@
       </p:sp>
       <p:sp>
         <p:nvSpPr>
-          <p:cNvPr id="19" name="Rectangle 18"/>
+          <p:cNvPr id="20" name="Rectangle 19"/>
           <p:cNvSpPr/>
           <p:nvPr/>
         </p:nvSpPr>
         <p:spPr>
           <a:xfrm>
-            <a:off x="0" y="7734300"/>
+            <a:off x="0" y="9048750"/>
             <a:ext cx="10287000" cy="19050"/>
           </a:xfrm>
           <a:prstGeom prst="rect">
@@ -7338,13 +7548,13 @@
       </p:sp>
       <p:sp>
         <p:nvSpPr>
-          <p:cNvPr id="20" name="Rectangle 19"/>
+          <p:cNvPr id="21" name="Rectangle 20"/>
           <p:cNvSpPr/>
           <p:nvPr/>
         </p:nvSpPr>
         <p:spPr>
           <a:xfrm>
-            <a:off x="0" y="9810750"/>
+            <a:off x="0" y="11144250"/>
             <a:ext cx="10287000" cy="38100"/>
           </a:xfrm>
           <a:prstGeom prst="rect">
@@ -7382,13 +7592,13 @@
       </p:sp>
       <p:sp>
         <p:nvSpPr>
-          <p:cNvPr id="21" name="TextBox 20"/>
+          <p:cNvPr id="22" name="TextBox 21"/>
           <p:cNvSpPr txBox="1"/>
           <p:nvPr/>
         </p:nvSpPr>
         <p:spPr>
           <a:xfrm>
-            <a:off x="762000" y="7905750"/>
+            <a:off x="762000" y="9191625"/>
             <a:ext cx="8572500" cy="1047750"/>
           </a:xfrm>
           <a:prstGeom prst="rect">
@@ -7421,13 +7631,13 @@
       </p:sp>
       <p:sp>
         <p:nvSpPr>
-          <p:cNvPr id="22" name="TextBox 21"/>
+          <p:cNvPr id="23" name="TextBox 22"/>
           <p:cNvSpPr txBox="1"/>
           <p:nvPr/>
         </p:nvSpPr>
         <p:spPr>
           <a:xfrm>
-            <a:off x="762000" y="8905875"/>
+            <a:off x="762000" y="10191750"/>
             <a:ext cx="8572500" cy="666750"/>
           </a:xfrm>
           <a:prstGeom prst="rect">
@@ -7454,6 +7664,45 @@
                 <a:latin typeface="Source Sans 3"/>
               </a:rPr>
               <a:t>MICROSCOPY</a:t>
+            </a:r>
+          </a:p>
+        </p:txBody>
+      </p:sp>
+      <p:sp>
+        <p:nvSpPr>
+          <p:cNvPr id="24" name="TextBox 23"/>
+          <p:cNvSpPr txBox="1"/>
+          <p:nvPr/>
+        </p:nvSpPr>
+        <p:spPr>
+          <a:xfrm>
+            <a:off x="762000" y="11763375"/>
+            <a:ext cx="8763000" cy="476250"/>
+          </a:xfrm>
+          <a:prstGeom prst="rect">
+            <a:avLst/>
+          </a:prstGeom>
+          <a:noFill/>
+        </p:spPr>
+        <p:txBody>
+          <a:bodyPr wrap="square" lIns="0" rIns="0" tIns="0" bIns="0" anchor="t">
+            <a:spAutoFit/>
+          </a:bodyPr>
+          <a:lstStyle/>
+          <a:p>
+            <a:pPr algn="l">
+              <a:lnSpc>
+                <a:spcPct val="120000"/>
+              </a:lnSpc>
+            </a:pPr>
+            <a:r>
+              <a:rPr sz="3000" b="0" i="0">
+                <a:solidFill>
+                  <a:srgbClr val="F4F1EA"/>
+                </a:solidFill>
+                <a:latin typeface="Source Sans 3"/>
+              </a:rPr>
+              <a:t>@soilfoodwebschool</a:t>
             </a:r>
           </a:p>
         </p:txBody>
@@ -7486,7 +7735,7 @@
       <p:grpSpPr/>
       <p:pic>
         <p:nvPicPr>
-          <p:cNvPr id="2" name="Picture 1" descr="7616125880658272022.jpg"/>
+          <p:cNvPr id="2" name="Picture 1" descr="5390912766246518019.jpg"/>
           <p:cNvPicPr>
             <a:picLocks noChangeAspect="1"/>
           </p:cNvPicPr>
@@ -7501,7 +7750,7 @@
         <p:spPr>
           <a:xfrm>
             <a:off x="0" y="0"/>
-            <a:ext cx="10287000" cy="12858750"/>
+            <a:ext cx="10287000" cy="9620250"/>
           </a:xfrm>
           <a:prstGeom prst="rect">
             <a:avLst/>
@@ -8181,11 +8430,11 @@
         <p:spPr>
           <a:xfrm>
             <a:off x="-571500" y="-571500"/>
-            <a:ext cx="5905500" cy="3048000"/>
+            <a:ext cx="4381500" cy="2476500"/>
           </a:xfrm>
           <a:prstGeom prst="roundRect">
             <a:avLst>
-              <a:gd name="adj" fmla="val 12500"/>
+              <a:gd name="adj" fmla="val 15384"/>
             </a:avLst>
           </a:prstGeom>
           <a:solidFill>
@@ -8228,8 +8477,8 @@
         </p:nvSpPr>
         <p:spPr>
           <a:xfrm>
-            <a:off x="666750" y="571500"/>
-            <a:ext cx="1238250" cy="1238250"/>
+            <a:off x="571500" y="476250"/>
+            <a:ext cx="952500" cy="952500"/>
           </a:xfrm>
           <a:prstGeom prst="ellipse">
             <a:avLst/>
@@ -8272,8 +8521,8 @@
         </p:nvSpPr>
         <p:spPr>
           <a:xfrm>
-            <a:off x="666750" y="571500"/>
-            <a:ext cx="1238250" cy="1238250"/>
+            <a:off x="571500" y="476250"/>
+            <a:ext cx="952500" cy="952500"/>
           </a:xfrm>
           <a:prstGeom prst="rect">
             <a:avLst/>
@@ -8311,8 +8560,8 @@
         </p:nvSpPr>
         <p:spPr>
           <a:xfrm>
-            <a:off x="2571750" y="666750"/>
-            <a:ext cx="19050" cy="1143000"/>
+            <a:off x="1809750" y="523875"/>
+            <a:ext cx="19050" cy="857250"/>
           </a:xfrm>
           <a:prstGeom prst="rect">
             <a:avLst/>
@@ -8355,8 +8604,8 @@
         </p:nvSpPr>
         <p:spPr>
           <a:xfrm>
-            <a:off x="3048000" y="571500"/>
-            <a:ext cx="1238250" cy="1238250"/>
+            <a:off x="2190750" y="476250"/>
+            <a:ext cx="952500" cy="952500"/>
           </a:xfrm>
           <a:prstGeom prst="ellipse">
             <a:avLst/>
@@ -8399,8 +8648,8 @@
         </p:nvSpPr>
         <p:spPr>
           <a:xfrm>
-            <a:off x="3048000" y="571500"/>
-            <a:ext cx="1238250" cy="1238250"/>
+            <a:off x="2190750" y="476250"/>
+            <a:ext cx="952500" cy="952500"/>
           </a:xfrm>
           <a:prstGeom prst="rect">
             <a:avLst/>
@@ -8438,7 +8687,51 @@
         </p:nvSpPr>
         <p:spPr>
           <a:xfrm>
-            <a:off x="0" y="7620000"/>
+            <a:off x="0" y="9620250"/>
+            <a:ext cx="10287000" cy="3238500"/>
+          </a:xfrm>
+          <a:prstGeom prst="rect">
+            <a:avLst/>
+          </a:prstGeom>
+          <a:solidFill>
+            <a:srgbClr val="22371F"/>
+          </a:solidFill>
+          <a:ln>
+            <a:noFill/>
+          </a:ln>
+          <a:effectLst/>
+        </p:spPr>
+        <p:style>
+          <a:lnRef idx="1">
+            <a:schemeClr val="accent1"/>
+          </a:lnRef>
+          <a:fillRef idx="3">
+            <a:schemeClr val="accent1"/>
+          </a:fillRef>
+          <a:effectRef idx="2">
+            <a:schemeClr val="accent1"/>
+          </a:effectRef>
+          <a:fontRef idx="minor">
+            <a:schemeClr val="lt1"/>
+          </a:fontRef>
+        </p:style>
+        <p:txBody>
+          <a:bodyPr rtlCol="0" anchor="ctr"/>
+          <a:lstStyle/>
+          <a:p>
+            <a:pPr algn="ctr"/>
+          </a:p>
+        </p:txBody>
+      </p:sp>
+      <p:sp>
+        <p:nvSpPr>
+          <p:cNvPr id="18" name="Rectangle 17"/>
+          <p:cNvSpPr/>
+          <p:nvPr/>
+        </p:nvSpPr>
+        <p:spPr>
+          <a:xfrm>
+            <a:off x="0" y="8953500"/>
             <a:ext cx="10287000" cy="2190750"/>
           </a:xfrm>
           <a:prstGeom prst="rect">
@@ -8446,7 +8739,7 @@
           </a:prstGeom>
           <a:solidFill>
             <a:srgbClr val="22371F">
-              <a:alpha val="72000"/>
+              <a:alpha val="78000"/>
             </a:srgbClr>
           </a:solidFill>
           <a:ln>
@@ -8478,13 +8771,13 @@
       </p:sp>
       <p:sp>
         <p:nvSpPr>
-          <p:cNvPr id="18" name="Rectangle 17"/>
+          <p:cNvPr id="19" name="Rectangle 18"/>
           <p:cNvSpPr/>
           <p:nvPr/>
         </p:nvSpPr>
         <p:spPr>
           <a:xfrm>
-            <a:off x="0" y="7581900"/>
+            <a:off x="0" y="8915400"/>
             <a:ext cx="10287000" cy="38100"/>
           </a:xfrm>
           <a:prstGeom prst="rect">
@@ -8522,13 +8815,13 @@
       </p:sp>
       <p:sp>
         <p:nvSpPr>
-          <p:cNvPr id="19" name="Rectangle 18"/>
+          <p:cNvPr id="20" name="Rectangle 19"/>
           <p:cNvSpPr/>
           <p:nvPr/>
         </p:nvSpPr>
         <p:spPr>
           <a:xfrm>
-            <a:off x="0" y="7734300"/>
+            <a:off x="0" y="9048750"/>
             <a:ext cx="10287000" cy="19050"/>
           </a:xfrm>
           <a:prstGeom prst="rect">
@@ -8566,13 +8859,13 @@
       </p:sp>
       <p:sp>
         <p:nvSpPr>
-          <p:cNvPr id="20" name="Rectangle 19"/>
+          <p:cNvPr id="21" name="Rectangle 20"/>
           <p:cNvSpPr/>
           <p:nvPr/>
         </p:nvSpPr>
         <p:spPr>
           <a:xfrm>
-            <a:off x="0" y="9810750"/>
+            <a:off x="0" y="11144250"/>
             <a:ext cx="10287000" cy="38100"/>
           </a:xfrm>
           <a:prstGeom prst="rect">
@@ -8610,13 +8903,13 @@
       </p:sp>
       <p:sp>
         <p:nvSpPr>
-          <p:cNvPr id="21" name="TextBox 20"/>
+          <p:cNvPr id="22" name="TextBox 21"/>
           <p:cNvSpPr txBox="1"/>
           <p:nvPr/>
         </p:nvSpPr>
         <p:spPr>
           <a:xfrm>
-            <a:off x="762000" y="7905750"/>
+            <a:off x="762000" y="9191625"/>
             <a:ext cx="8572500" cy="1047750"/>
           </a:xfrm>
           <a:prstGeom prst="rect">
@@ -8649,13 +8942,13 @@
       </p:sp>
       <p:sp>
         <p:nvSpPr>
-          <p:cNvPr id="22" name="TextBox 21"/>
+          <p:cNvPr id="23" name="TextBox 22"/>
           <p:cNvSpPr txBox="1"/>
           <p:nvPr/>
         </p:nvSpPr>
         <p:spPr>
           <a:xfrm>
-            <a:off x="762000" y="8905875"/>
+            <a:off x="762000" y="10191750"/>
             <a:ext cx="8572500" cy="666750"/>
           </a:xfrm>
           <a:prstGeom prst="rect">
@@ -8682,6 +8975,45 @@
                 <a:latin typeface="Source Sans 3"/>
               </a:rPr>
               <a:t>COMPOST EXTRACTS AND TEAS</a:t>
+            </a:r>
+          </a:p>
+        </p:txBody>
+      </p:sp>
+      <p:sp>
+        <p:nvSpPr>
+          <p:cNvPr id="24" name="TextBox 23"/>
+          <p:cNvSpPr txBox="1"/>
+          <p:nvPr/>
+        </p:nvSpPr>
+        <p:spPr>
+          <a:xfrm>
+            <a:off x="762000" y="11763375"/>
+            <a:ext cx="8763000" cy="476250"/>
+          </a:xfrm>
+          <a:prstGeom prst="rect">
+            <a:avLst/>
+          </a:prstGeom>
+          <a:noFill/>
+        </p:spPr>
+        <p:txBody>
+          <a:bodyPr wrap="square" lIns="0" rIns="0" tIns="0" bIns="0" anchor="t">
+            <a:spAutoFit/>
+          </a:bodyPr>
+          <a:lstStyle/>
+          <a:p>
+            <a:pPr algn="l">
+              <a:lnSpc>
+                <a:spcPct val="120000"/>
+              </a:lnSpc>
+            </a:pPr>
+            <a:r>
+              <a:rPr sz="3000" b="0" i="0">
+                <a:solidFill>
+                  <a:srgbClr val="F4F1EA"/>
+                </a:solidFill>
+                <a:latin typeface="Source Sans 3"/>
+              </a:rPr>
+              <a:t>@soilfoodwebschool</a:t>
             </a:r>
           </a:p>
         </p:txBody>
@@ -8721,7 +9053,7 @@
         <p:spPr>
           <a:xfrm>
             <a:off x="0" y="0"/>
-            <a:ext cx="10287000" cy="12858750"/>
+            <a:ext cx="10287000" cy="9620250"/>
           </a:xfrm>
           <a:prstGeom prst="rect">
             <a:avLst/>
@@ -8765,7 +9097,7 @@
         <p:spPr>
           <a:xfrm>
             <a:off x="152400" y="0"/>
-            <a:ext cx="9982200" cy="12858750"/>
+            <a:ext cx="9982200" cy="9620250"/>
           </a:xfrm>
           <a:prstGeom prst="rect">
             <a:avLst/>
@@ -9468,11 +9800,11 @@
         <p:spPr>
           <a:xfrm>
             <a:off x="-571500" y="-571500"/>
-            <a:ext cx="5905500" cy="3048000"/>
+            <a:ext cx="4381500" cy="2476500"/>
           </a:xfrm>
           <a:prstGeom prst="roundRect">
             <a:avLst>
-              <a:gd name="adj" fmla="val 12500"/>
+              <a:gd name="adj" fmla="val 15384"/>
             </a:avLst>
           </a:prstGeom>
           <a:solidFill>
@@ -9515,8 +9847,8 @@
         </p:nvSpPr>
         <p:spPr>
           <a:xfrm>
-            <a:off x="666750" y="571500"/>
-            <a:ext cx="1238250" cy="1238250"/>
+            <a:off x="571500" y="476250"/>
+            <a:ext cx="952500" cy="952500"/>
           </a:xfrm>
           <a:prstGeom prst="ellipse">
             <a:avLst/>
@@ -9559,8 +9891,8 @@
         </p:nvSpPr>
         <p:spPr>
           <a:xfrm>
-            <a:off x="666750" y="571500"/>
-            <a:ext cx="1238250" cy="1238250"/>
+            <a:off x="571500" y="476250"/>
+            <a:ext cx="952500" cy="952500"/>
           </a:xfrm>
           <a:prstGeom prst="rect">
             <a:avLst/>
@@ -9598,8 +9930,8 @@
         </p:nvSpPr>
         <p:spPr>
           <a:xfrm>
-            <a:off x="2571750" y="666750"/>
-            <a:ext cx="19050" cy="1143000"/>
+            <a:off x="1809750" y="523875"/>
+            <a:ext cx="19050" cy="857250"/>
           </a:xfrm>
           <a:prstGeom prst="rect">
             <a:avLst/>
@@ -9642,8 +9974,8 @@
         </p:nvSpPr>
         <p:spPr>
           <a:xfrm>
-            <a:off x="3048000" y="571500"/>
-            <a:ext cx="1238250" cy="1238250"/>
+            <a:off x="2190750" y="476250"/>
+            <a:ext cx="952500" cy="952500"/>
           </a:xfrm>
           <a:prstGeom prst="ellipse">
             <a:avLst/>
@@ -9686,8 +10018,8 @@
         </p:nvSpPr>
         <p:spPr>
           <a:xfrm>
-            <a:off x="3048000" y="571500"/>
-            <a:ext cx="1238250" cy="1238250"/>
+            <a:off x="2190750" y="476250"/>
+            <a:ext cx="952500" cy="952500"/>
           </a:xfrm>
           <a:prstGeom prst="rect">
             <a:avLst/>
@@ -9725,7 +10057,51 @@
         </p:nvSpPr>
         <p:spPr>
           <a:xfrm>
-            <a:off x="0" y="7620000"/>
+            <a:off x="0" y="9620250"/>
+            <a:ext cx="10287000" cy="3238500"/>
+          </a:xfrm>
+          <a:prstGeom prst="rect">
+            <a:avLst/>
+          </a:prstGeom>
+          <a:solidFill>
+            <a:srgbClr val="22371F"/>
+          </a:solidFill>
+          <a:ln>
+            <a:noFill/>
+          </a:ln>
+          <a:effectLst/>
+        </p:spPr>
+        <p:style>
+          <a:lnRef idx="1">
+            <a:schemeClr val="accent1"/>
+          </a:lnRef>
+          <a:fillRef idx="3">
+            <a:schemeClr val="accent1"/>
+          </a:fillRef>
+          <a:effectRef idx="2">
+            <a:schemeClr val="accent1"/>
+          </a:effectRef>
+          <a:fontRef idx="minor">
+            <a:schemeClr val="lt1"/>
+          </a:fontRef>
+        </p:style>
+        <p:txBody>
+          <a:bodyPr rtlCol="0" anchor="ctr"/>
+          <a:lstStyle/>
+          <a:p>
+            <a:pPr algn="ctr"/>
+          </a:p>
+        </p:txBody>
+      </p:sp>
+      <p:sp>
+        <p:nvSpPr>
+          <p:cNvPr id="19" name="Rectangle 18"/>
+          <p:cNvSpPr/>
+          <p:nvPr/>
+        </p:nvSpPr>
+        <p:spPr>
+          <a:xfrm>
+            <a:off x="0" y="8953500"/>
             <a:ext cx="10287000" cy="2190750"/>
           </a:xfrm>
           <a:prstGeom prst="rect">
@@ -9733,7 +10109,7 @@
           </a:prstGeom>
           <a:solidFill>
             <a:srgbClr val="22371F">
-              <a:alpha val="72000"/>
+              <a:alpha val="78000"/>
             </a:srgbClr>
           </a:solidFill>
           <a:ln>
@@ -9765,13 +10141,13 @@
       </p:sp>
       <p:sp>
         <p:nvSpPr>
-          <p:cNvPr id="19" name="Rectangle 18"/>
+          <p:cNvPr id="20" name="Rectangle 19"/>
           <p:cNvSpPr/>
           <p:nvPr/>
         </p:nvSpPr>
         <p:spPr>
           <a:xfrm>
-            <a:off x="0" y="7581900"/>
+            <a:off x="0" y="8915400"/>
             <a:ext cx="10287000" cy="38100"/>
           </a:xfrm>
           <a:prstGeom prst="rect">
@@ -9809,13 +10185,13 @@
       </p:sp>
       <p:sp>
         <p:nvSpPr>
-          <p:cNvPr id="20" name="Rectangle 19"/>
+          <p:cNvPr id="21" name="Rectangle 20"/>
           <p:cNvSpPr/>
           <p:nvPr/>
         </p:nvSpPr>
         <p:spPr>
           <a:xfrm>
-            <a:off x="0" y="7734300"/>
+            <a:off x="0" y="9048750"/>
             <a:ext cx="10287000" cy="19050"/>
           </a:xfrm>
           <a:prstGeom prst="rect">
@@ -9853,13 +10229,13 @@
       </p:sp>
       <p:sp>
         <p:nvSpPr>
-          <p:cNvPr id="21" name="Rectangle 20"/>
+          <p:cNvPr id="22" name="Rectangle 21"/>
           <p:cNvSpPr/>
           <p:nvPr/>
         </p:nvSpPr>
         <p:spPr>
           <a:xfrm>
-            <a:off x="0" y="9810750"/>
+            <a:off x="0" y="11144250"/>
             <a:ext cx="10287000" cy="38100"/>
           </a:xfrm>
           <a:prstGeom prst="rect">
@@ -9897,13 +10273,13 @@
       </p:sp>
       <p:sp>
         <p:nvSpPr>
-          <p:cNvPr id="22" name="TextBox 21"/>
+          <p:cNvPr id="23" name="TextBox 22"/>
           <p:cNvSpPr txBox="1"/>
           <p:nvPr/>
         </p:nvSpPr>
         <p:spPr>
           <a:xfrm>
-            <a:off x="762000" y="7905750"/>
+            <a:off x="762000" y="9191625"/>
             <a:ext cx="8572500" cy="1047750"/>
           </a:xfrm>
           <a:prstGeom prst="rect">
@@ -9936,13 +10312,13 @@
       </p:sp>
       <p:sp>
         <p:nvSpPr>
-          <p:cNvPr id="23" name="TextBox 22"/>
+          <p:cNvPr id="24" name="TextBox 23"/>
           <p:cNvSpPr txBox="1"/>
           <p:nvPr/>
         </p:nvSpPr>
         <p:spPr>
           <a:xfrm>
-            <a:off x="762000" y="8905875"/>
+            <a:off x="762000" y="10191750"/>
             <a:ext cx="8572500" cy="666750"/>
           </a:xfrm>
           <a:prstGeom prst="rect">
@@ -9969,6 +10345,45 @@
                 <a:latin typeface="Source Sans 3"/>
               </a:rPr>
               <a:t>ADVANCED PROGRAMS</a:t>
+            </a:r>
+          </a:p>
+        </p:txBody>
+      </p:sp>
+      <p:sp>
+        <p:nvSpPr>
+          <p:cNvPr id="25" name="TextBox 24"/>
+          <p:cNvSpPr txBox="1"/>
+          <p:nvPr/>
+        </p:nvSpPr>
+        <p:spPr>
+          <a:xfrm>
+            <a:off x="762000" y="11763375"/>
+            <a:ext cx="8763000" cy="476250"/>
+          </a:xfrm>
+          <a:prstGeom prst="rect">
+            <a:avLst/>
+          </a:prstGeom>
+          <a:noFill/>
+        </p:spPr>
+        <p:txBody>
+          <a:bodyPr wrap="square" lIns="0" rIns="0" tIns="0" bIns="0" anchor="t">
+            <a:spAutoFit/>
+          </a:bodyPr>
+          <a:lstStyle/>
+          <a:p>
+            <a:pPr algn="l">
+              <a:lnSpc>
+                <a:spcPct val="120000"/>
+              </a:lnSpc>
+            </a:pPr>
+            <a:r>
+              <a:rPr sz="3000" b="0" i="0">
+                <a:solidFill>
+                  <a:srgbClr val="F4F1EA"/>
+                </a:solidFill>
+                <a:latin typeface="Source Sans 3"/>
+              </a:rPr>
+              <a:t>@soilfoodwebschool</a:t>
             </a:r>
           </a:p>
         </p:txBody>

</xml_diff>